<commit_message>
Ganti nama berkas contoh agar sesuai aturan penamaan Dart
Nama berkas yang diawali angka (misalnya 01_aplikasi_pertama.dart)
melanggar lint file_names sehingga quality gate gagal. Semua contoh kini
memakai pola contoh_NN_nama.dart, dan tautan di README, modul, jobsheet,
latihan, panduan, serta slide ikut diperbarui. Nama berkas pengumpulan
tugas juga diubah menjadi huruf kecil (p01_nim_namapanggilan.dart).

Co-Authored-By: Claude Opus 5.5 <noreply@anthropic.com>
Claude-Session: https://claude.ai/code/session_01J7XZK1Ud7CGMnzy7EH5FMS
</commit_message>
<xml_diff>
--- a/pertemuan_01_pengenalan_flutter/slide/PERTEMUAN_01_Pengenalan_Flutter.pptx
+++ b/pertemuan_01_pengenalan_flutter/slide/PERTEMUAN_01_Pengenalan_Flutter.pptx
@@ -133,14 +133,14 @@
   <p:extLst>
     <p:ext uri="{521415D9-36F7-43E2-AB2F-B90AF26B5E84}">
       <p14:sectionLst xmlns:p14="http://schemas.microsoft.com/office/powerpoint/2010/main">
-        <p14:section name="Pembuka" id="{3811ae53-2f0b-a551-2ed9-9ae21bce7f4b}">
+        <p14:section name="Pembuka" id="{9814c19b-9a5d-7374-6268-cce7746ed3af}">
           <p14:sldIdLst>
             <p14:sldId id="256"/>
             <p14:sldId id="257"/>
             <p14:sldId id="258"/>
           </p14:sldIdLst>
         </p14:section>
-        <p14:section name="Mengenal Dunia Aplikasi Mobile" id="{4fa511fa-8b5d-9974-fcbe-523cdf8a5628}">
+        <p14:section name="Mengenal Dunia Aplikasi Mobile" id="{f06325b5-6e22-b479-95ad-7d91b2f3a752}">
           <p14:sldIdLst>
             <p14:sldId id="259"/>
             <p14:sldId id="260"/>
@@ -151,14 +151,14 @@
             <p14:sldId id="265"/>
           </p14:sldIdLst>
         </p14:section>
-        <p14:section name="Siklus Hidup (Lifecycle) Aplikasi" id="{5dd3b44d-c8cd-aabe-dafb-ccba5d8ce77f}">
+        <p14:section name="Siklus Hidup (Lifecycle) Aplikasi" id="{2784f7d3-54dc-0bf9-96ad-73f5170ec9a7}">
           <p14:sldIdLst>
             <p14:sldId id="266"/>
             <p14:sldId id="267"/>
             <p14:sldId id="268"/>
           </p14:sldIdLst>
         </p14:section>
-        <p14:section name="Menyiapkan Alat &amp; Proyek Pertama" id="{932a8960-2be2-98f9-fe8a-be4ba5f7f727}">
+        <p14:section name="Menyiapkan Alat &amp; Proyek Pertama" id="{48bdc4c2-076f-465d-5bbc-31e27d978e6a}">
           <p14:sldIdLst>
             <p14:sldId id="269"/>
             <p14:sldId id="270"/>
@@ -7215,7 +7215,7 @@
       <p:sp>
         <p:nvSpPr>
           <p:cNvPr id="5" name="tombol tautan">
-            <a:hlinkClick r:id="rId1" tooltip="https://github.com/antonprafanto/mobile2026/blob/main/pertemuan_01_pengenalan_flutter/kode/06_siklus_hidup_aplikasi.dart"/>
+            <a:hlinkClick r:id="rId1" tooltip="https://github.com/antonprafanto/mobile2026/blob/main/pertemuan_01_pengenalan_flutter/kode/contoh_06_siklus_hidup_aplikasi.dart"/>
           </p:cNvPr>
           <p:cNvSpPr txBox="1"/>
           <p:nvPr/>
@@ -7248,7 +7248,7 @@
                   <a:schemeClr val="bg1"/>
                 </a:solidFill>
               </a:rPr>
-              <a:t>Buka kode lengkap di GitHub  ·  06_siklus_hidup_aplikasi.dart</a:t>
+              <a:t>Buka kode lengkap di GitHub  ·  contoh_06_siklus_hidup_aplikasi.dart</a:t>
             </a:r>
             <a:endParaRPr lang="en-US" sz="1300" dirty="0"/>
           </a:p>
@@ -7257,7 +7257,7 @@
       <p:pic>
         <p:nvPicPr>
           <p:cNvPr id="6" name="Image 0" descr="ikon tautan">
-            <a:hlinkClick r:id="rId3" tooltip="https://github.com/antonprafanto/mobile2026/blob/main/pertemuan_01_pengenalan_flutter/kode/06_siklus_hidup_aplikasi.dart"/>
+            <a:hlinkClick r:id="rId3" tooltip="https://github.com/antonprafanto/mobile2026/blob/main/pertemuan_01_pengenalan_flutter/kode/contoh_06_siklus_hidup_aplikasi.dart"/>
           </p:cNvPr>
           <p:cNvPicPr>
             <a:picLocks noChangeAspect="1"/>
@@ -13339,7 +13339,7 @@
       <p:sp>
         <p:nvSpPr>
           <p:cNvPr id="5" name="tombol tautan">
-            <a:hlinkClick r:id="rId1" tooltip="https://github.com/antonprafanto/mobile2026/blob/main/pertemuan_01_pengenalan_flutter/kode/01_aplikasi_pertama.dart"/>
+            <a:hlinkClick r:id="rId1" tooltip="https://github.com/antonprafanto/mobile2026/blob/main/pertemuan_01_pengenalan_flutter/kode/contoh_01_aplikasi_pertama.dart"/>
           </p:cNvPr>
           <p:cNvSpPr txBox="1"/>
           <p:nvPr/>
@@ -13372,7 +13372,7 @@
                   <a:schemeClr val="bg1"/>
                 </a:solidFill>
               </a:rPr>
-              <a:t>Buka kode lengkap di GitHub  ·  01_aplikasi_pertama.dart</a:t>
+              <a:t>Buka kode lengkap di GitHub  ·  contoh_01_aplikasi_pertama.dart</a:t>
             </a:r>
             <a:endParaRPr lang="en-US" sz="1300" dirty="0"/>
           </a:p>
@@ -13381,7 +13381,7 @@
       <p:pic>
         <p:nvPicPr>
           <p:cNvPr id="6" name="Image 0" descr="ikon tautan">
-            <a:hlinkClick r:id="rId3" tooltip="https://github.com/antonprafanto/mobile2026/blob/main/pertemuan_01_pengenalan_flutter/kode/01_aplikasi_pertama.dart"/>
+            <a:hlinkClick r:id="rId3" tooltip="https://github.com/antonprafanto/mobile2026/blob/main/pertemuan_01_pengenalan_flutter/kode/contoh_01_aplikasi_pertama.dart"/>
           </p:cNvPr>
           <p:cNvPicPr>
             <a:picLocks noChangeAspect="1"/>
@@ -14774,7 +14774,7 @@
       <p:sp>
         <p:nvSpPr>
           <p:cNvPr id="5" name="tombol tautan">
-            <a:hlinkClick r:id="rId1" tooltip="https://github.com/antonprafanto/mobile2026/blob/main/pertemuan_01_pengenalan_flutter/kode/02_materialapp_dan_scaffold.dart"/>
+            <a:hlinkClick r:id="rId1" tooltip="https://github.com/antonprafanto/mobile2026/blob/main/pertemuan_01_pengenalan_flutter/kode/contoh_02_materialapp_dan_scaffold.dart"/>
           </p:cNvPr>
           <p:cNvSpPr txBox="1"/>
           <p:nvPr/>
@@ -14807,7 +14807,7 @@
                   <a:schemeClr val="bg1"/>
                 </a:solidFill>
               </a:rPr>
-              <a:t>Buka kode lengkap di GitHub  ·  02_materialapp_dan_scaffold.dart</a:t>
+              <a:t>Buka kode lengkap di GitHub  ·  contoh_02_materialapp_dan_scaffold.dart</a:t>
             </a:r>
             <a:endParaRPr lang="en-US" sz="1300" dirty="0"/>
           </a:p>
@@ -14816,7 +14816,7 @@
       <p:pic>
         <p:nvPicPr>
           <p:cNvPr id="6" name="Image 0" descr="ikon tautan">
-            <a:hlinkClick r:id="rId3" tooltip="https://github.com/antonprafanto/mobile2026/blob/main/pertemuan_01_pengenalan_flutter/kode/02_materialapp_dan_scaffold.dart"/>
+            <a:hlinkClick r:id="rId3" tooltip="https://github.com/antonprafanto/mobile2026/blob/main/pertemuan_01_pengenalan_flutter/kode/contoh_02_materialapp_dan_scaffold.dart"/>
           </p:cNvPr>
           <p:cNvPicPr>
             <a:picLocks noChangeAspect="1"/>
@@ -15690,7 +15690,7 @@
       <p:sp>
         <p:nvSpPr>
           <p:cNvPr id="5" name="tombol tautan">
-            <a:hlinkClick r:id="rId1" tooltip="https://github.com/antonprafanto/mobile2026/blob/main/pertemuan_01_pengenalan_flutter/kode/03_tema_warna_dan_teks.dart"/>
+            <a:hlinkClick r:id="rId1" tooltip="https://github.com/antonprafanto/mobile2026/blob/main/pertemuan_01_pengenalan_flutter/kode/contoh_03_tema_warna_dan_teks.dart"/>
           </p:cNvPr>
           <p:cNvSpPr txBox="1"/>
           <p:nvPr/>
@@ -15723,7 +15723,7 @@
                   <a:schemeClr val="bg1"/>
                 </a:solidFill>
               </a:rPr>
-              <a:t>Buka kode lengkap di GitHub  ·  03_tema_warna_dan_teks.dart</a:t>
+              <a:t>Buka kode lengkap di GitHub  ·  contoh_03_tema_warna_dan_teks.dart</a:t>
             </a:r>
             <a:endParaRPr lang="en-US" sz="1300" dirty="0"/>
           </a:p>
@@ -15732,7 +15732,7 @@
       <p:pic>
         <p:nvPicPr>
           <p:cNvPr id="6" name="Image 0" descr="ikon tautan">
-            <a:hlinkClick r:id="rId3" tooltip="https://github.com/antonprafanto/mobile2026/blob/main/pertemuan_01_pengenalan_flutter/kode/03_tema_warna_dan_teks.dart"/>
+            <a:hlinkClick r:id="rId3" tooltip="https://github.com/antonprafanto/mobile2026/blob/main/pertemuan_01_pengenalan_flutter/kode/contoh_03_tema_warna_dan_teks.dart"/>
           </p:cNvPr>
           <p:cNvPicPr>
             <a:picLocks noChangeAspect="1"/>
@@ -17198,7 +17198,7 @@
       <p:sp>
         <p:nvSpPr>
           <p:cNvPr id="5" name="tombol tautan">
-            <a:hlinkClick r:id="rId1" tooltip="https://github.com/antonprafanto/mobile2026/blob/main/pertemuan_01_pengenalan_flutter/kode/04_hot_reload_vs_hot_restart.dart"/>
+            <a:hlinkClick r:id="rId1" tooltip="https://github.com/antonprafanto/mobile2026/blob/main/pertemuan_01_pengenalan_flutter/kode/contoh_04_hot_reload_vs_hot_restart.dart"/>
           </p:cNvPr>
           <p:cNvSpPr txBox="1"/>
           <p:nvPr/>
@@ -17231,7 +17231,7 @@
                   <a:schemeClr val="bg1"/>
                 </a:solidFill>
               </a:rPr>
-              <a:t>Buka kode lengkap di GitHub  ·  04_hot_reload_vs_hot_restart.dart</a:t>
+              <a:t>Buka kode lengkap di GitHub  ·  contoh_04_hot_reload_vs_hot_restart.dart</a:t>
             </a:r>
             <a:endParaRPr lang="en-US" sz="1300" dirty="0"/>
           </a:p>
@@ -17240,7 +17240,7 @@
       <p:pic>
         <p:nvPicPr>
           <p:cNvPr id="6" name="Image 0" descr="ikon tautan">
-            <a:hlinkClick r:id="rId3" tooltip="https://github.com/antonprafanto/mobile2026/blob/main/pertemuan_01_pengenalan_flutter/kode/04_hot_reload_vs_hot_restart.dart"/>
+            <a:hlinkClick r:id="rId3" tooltip="https://github.com/antonprafanto/mobile2026/blob/main/pertemuan_01_pengenalan_flutter/kode/contoh_04_hot_reload_vs_hot_restart.dart"/>
           </p:cNvPr>
           <p:cNvPicPr>
             <a:picLocks noChangeAspect="1"/>
@@ -18360,7 +18360,7 @@
       <p:sp>
         <p:nvSpPr>
           <p:cNvPr id="39" name="tombol tautan">
-            <a:hlinkClick r:id="rId6" tooltip="https://github.com/antonprafanto/mobile2026/blob/main/pertemuan_01_pengenalan_flutter/kode/05_aplikasi_counter_bawaan.dart"/>
+            <a:hlinkClick r:id="rId6" tooltip="https://github.com/antonprafanto/mobile2026/blob/main/pertemuan_01_pengenalan_flutter/kode/contoh_05_aplikasi_counter_bawaan.dart"/>
           </p:cNvPr>
           <p:cNvSpPr txBox="1"/>
           <p:nvPr/>
@@ -18393,7 +18393,7 @@
                   <a:schemeClr val="bg1"/>
                 </a:solidFill>
               </a:rPr>
-              <a:t>Buka kode lengkap di GitHub  ·  05_aplikasi_counter_bawaan.dart</a:t>
+              <a:t>Buka kode lengkap di GitHub  ·  contoh_05_aplikasi_counter_bawaan.dart</a:t>
             </a:r>
             <a:endParaRPr lang="en-US" sz="1300" dirty="0"/>
           </a:p>
@@ -18402,7 +18402,7 @@
       <p:pic>
         <p:nvPicPr>
           <p:cNvPr id="40" name="Image 5" descr="ikon tautan">
-            <a:hlinkClick r:id="rId8" tooltip="https://github.com/antonprafanto/mobile2026/blob/main/pertemuan_01_pengenalan_flutter/kode/05_aplikasi_counter_bawaan.dart"/>
+            <a:hlinkClick r:id="rId8" tooltip="https://github.com/antonprafanto/mobile2026/blob/main/pertemuan_01_pengenalan_flutter/kode/contoh_05_aplikasi_counter_bawaan.dart"/>
           </p:cNvPr>
           <p:cNvPicPr>
             <a:picLocks noChangeAspect="1"/>

</xml_diff>